<commit_message>
Clarify meta-analysis significance/heterogeneity and add HCC-ICI intro slide
Slide 8 (meta-analysis): explanation now explicitly separates two
distinct questions the user was conflating - "is the pooled effect
significant" (yes, p=0.010, despite one individually-underpowered
input cohort) vs. "is the effect size consistent across cohorts"
(no, I2=83.5%) - so a viewer doesn't read the high heterogeneity as
meaning the significant pooled result isn't real.

New slide 12: a plain-text transition slide defining HCC/ICI/cohort
and explaining why the analysis pivots from fibrosis tissue to HCC
immunotherapy-response data at this point in the deck (18 slides
total now, was 17).
</commit_message>
<xml_diff>
--- a/presentation/dry_lab_summary.pptx
+++ b/presentation/dry_lab_summary.pptx
@@ -22,6 +22,7 @@
     <p:sldId id="270" r:id="rId21"/>
     <p:sldId id="271" r:id="rId22"/>
     <p:sldId id="272" r:id="rId23"/>
+    <p:sldId id="273" r:id="rId24"/>
   </p:sldIdLst>
   <p:sldSz cx="12191695" cy="6858000" type="screen4x3"/>
   <p:notesSz cx="6858000" cy="9144000"/>
@@ -5463,6 +5464,181 @@
               </a:defRPr>
             </a:pPr>
             <a:r>
+              <a:t>Next: A Different Question — Does This Matter Clinically?</a:t>
+            </a:r>
+          </a:p>
+        </p:txBody>
+      </p:sp>
+      <p:sp>
+        <p:nvSpPr>
+          <p:cNvPr id="3" name="TextBox 2"/>
+          <p:cNvSpPr txBox="1"/>
+          <p:nvPr/>
+        </p:nvSpPr>
+        <p:spPr>
+          <a:xfrm>
+            <a:off x="457200" y="1188720"/>
+            <a:ext cx="11277295" cy="5120640"/>
+          </a:xfrm>
+          <a:prstGeom prst="rect">
+            <a:avLst/>
+          </a:prstGeom>
+          <a:noFill/>
+        </p:spPr>
+        <p:txBody>
+          <a:bodyPr wrap="square">
+            <a:spAutoFit/>
+          </a:bodyPr>
+          <a:lstStyle/>
+          <a:p>
+            <a:pPr algn="l">
+              <a:defRPr sz="1600" b="0" i="0">
+                <a:solidFill>
+                  <a:srgbClr val="000000"/>
+                </a:solidFill>
+                <a:latin typeface="Calibri"/>
+              </a:defRPr>
+            </a:pPr>
+            <a:r>
+              <a:t>So far: fibrosis tissue (not cancer) — testing whether HSF2 relates to NETosis genes at all. The next 3 slides switch to a different question and a different kind of data.</a:t>
+            </a:r>
+          </a:p>
+          <a:p>
+            <a:pPr algn="l">
+              <a:defRPr sz="1600" b="0" i="0">
+                <a:solidFill>
+                  <a:srgbClr val="000000"/>
+                </a:solidFill>
+                <a:latin typeface="Calibri"/>
+              </a:defRPr>
+            </a:pPr>
+          </a:p>
+          <a:p>
+            <a:pPr algn="l">
+              <a:defRPr sz="1600" b="0" i="0">
+                <a:solidFill>
+                  <a:srgbClr val="000000"/>
+                </a:solidFill>
+                <a:latin typeface="Calibri"/>
+              </a:defRPr>
+            </a:pPr>
+            <a:r>
+              <a:t>HCC-ICI = Hepatocellular Carcinoma + Immune Checkpoint Inhibitor.</a:t>
+            </a:r>
+          </a:p>
+          <a:p>
+            <a:pPr algn="l">
+              <a:defRPr sz="1600" b="0" i="0">
+                <a:solidFill>
+                  <a:srgbClr val="000000"/>
+                </a:solidFill>
+                <a:latin typeface="Calibri"/>
+              </a:defRPr>
+            </a:pPr>
+            <a:r>
+              <a:t>  - HCC: liver cancer</a:t>
+            </a:r>
+          </a:p>
+          <a:p>
+            <a:pPr algn="l">
+              <a:defRPr sz="1600" b="0" i="0">
+                <a:solidFill>
+                  <a:srgbClr val="000000"/>
+                </a:solidFill>
+                <a:latin typeface="Calibri"/>
+              </a:defRPr>
+            </a:pPr>
+            <a:r>
+              <a:t>  - ICI: immune checkpoint inhibitor drugs (anti-PD-1 / anti-PD-L1 immunotherapy)</a:t>
+            </a:r>
+          </a:p>
+          <a:p>
+            <a:pPr algn="l">
+              <a:defRPr sz="1600" b="0" i="0">
+                <a:solidFill>
+                  <a:srgbClr val="000000"/>
+                </a:solidFill>
+                <a:latin typeface="Calibri"/>
+              </a:defRPr>
+            </a:pPr>
+            <a:r>
+              <a:t>  - "Cohort": real liver-cancer patients who received these drugs, each labeled Responder or Non-responder, with tumor RNA-seq data available</a:t>
+            </a:r>
+          </a:p>
+          <a:p>
+            <a:pPr algn="l">
+              <a:defRPr sz="1600" b="0" i="0">
+                <a:solidFill>
+                  <a:srgbClr val="000000"/>
+                </a:solidFill>
+                <a:latin typeface="Calibri"/>
+              </a:defRPr>
+            </a:pPr>
+          </a:p>
+          <a:p>
+            <a:pPr algn="l">
+              <a:defRPr sz="1600" b="0" i="0">
+                <a:solidFill>
+                  <a:srgbClr val="000000"/>
+                </a:solidFill>
+                <a:latin typeface="Calibri"/>
+              </a:defRPr>
+            </a:pPr>
+            <a:r>
+              <a:t>Why look at this: a prior published study (Chen et al., 2022) already showed HSF2 is elevated in liver cancer and correlates with immune-checkpoint gene expression. So beyond the fibrosis/NETosis question, we also asked: does tumor HSF2 relate to whether real HCC patients actually respond to immunotherapy? This tests whether the HSF2 axis has direct clinical relevance, not just a tissue-level correlation.</a:t>
+            </a:r>
+          </a:p>
+        </p:txBody>
+      </p:sp>
+    </p:spTree>
+  </p:cSld>
+  <p:clrMapOvr>
+    <a:masterClrMapping/>
+  </p:clrMapOvr>
+</p:sld>
+</file>
+
+<file path=ppt/slides/slide13.xml><?xml version="1.0" encoding="utf-8"?>
+<p:sld xmlns:a="http://schemas.openxmlformats.org/drawingml/2006/main" xmlns:p="http://schemas.openxmlformats.org/presentationml/2006/main" xmlns:r="http://schemas.openxmlformats.org/officeDocument/2006/relationships">
+  <p:cSld>
+    <p:spTree>
+      <p:nvGrpSpPr>
+        <p:cNvPr id="1" name=""/>
+        <p:cNvGrpSpPr/>
+        <p:nvPr/>
+      </p:nvGrpSpPr>
+      <p:grpSpPr/>
+      <p:sp>
+        <p:nvSpPr>
+          <p:cNvPr id="2" name="TextBox 1"/>
+          <p:cNvSpPr txBox="1"/>
+          <p:nvPr/>
+        </p:nvSpPr>
+        <p:spPr>
+          <a:xfrm>
+            <a:off x="457200" y="274320"/>
+            <a:ext cx="11277295" cy="731520"/>
+          </a:xfrm>
+          <a:prstGeom prst="rect">
+            <a:avLst/>
+          </a:prstGeom>
+          <a:noFill/>
+        </p:spPr>
+        <p:txBody>
+          <a:bodyPr wrap="square">
+            <a:spAutoFit/>
+          </a:bodyPr>
+          <a:lstStyle/>
+          <a:p>
+            <a:pPr>
+              <a:defRPr sz="2800" b="1">
+                <a:solidFill>
+                  <a:srgbClr val="000000"/>
+                </a:solidFill>
+                <a:latin typeface="Calibri"/>
+              </a:defRPr>
+            </a:pPr>
+            <a:r>
               <a:t>HCC Immunotherapy: Dataset Gate-Check + First Cohort (GSE215011)</a:t>
             </a:r>
           </a:p>
@@ -5777,7 +5953,7 @@
 </p:sld>
 </file>
 
-<file path=ppt/slides/slide13.xml><?xml version="1.0" encoding="utf-8"?>
+<file path=ppt/slides/slide14.xml><?xml version="1.0" encoding="utf-8"?>
 <p:sld xmlns:a="http://schemas.openxmlformats.org/drawingml/2006/main" xmlns:p="http://schemas.openxmlformats.org/presentationml/2006/main" xmlns:r="http://schemas.openxmlformats.org/officeDocument/2006/relationships">
   <p:cSld>
     <p:spTree>
@@ -6093,7 +6269,7 @@
 </p:sld>
 </file>
 
-<file path=ppt/slides/slide14.xml><?xml version="1.0" encoding="utf-8"?>
+<file path=ppt/slides/slide15.xml><?xml version="1.0" encoding="utf-8"?>
 <p:sld xmlns:a="http://schemas.openxmlformats.org/drawingml/2006/main" xmlns:p="http://schemas.openxmlformats.org/presentationml/2006/main" xmlns:r="http://schemas.openxmlformats.org/officeDocument/2006/relationships">
   <p:cSld>
     <p:spTree>
@@ -6448,7 +6624,7 @@
 </p:sld>
 </file>
 
-<file path=ppt/slides/slide15.xml><?xml version="1.0" encoding="utf-8"?>
+<file path=ppt/slides/slide16.xml><?xml version="1.0" encoding="utf-8"?>
 <p:sld xmlns:a="http://schemas.openxmlformats.org/drawingml/2006/main" xmlns:p="http://schemas.openxmlformats.org/presentationml/2006/main" xmlns:r="http://schemas.openxmlformats.org/officeDocument/2006/relationships">
   <p:cSld>
     <p:spTree>
@@ -6630,7 +6806,7 @@
 </p:sld>
 </file>
 
-<file path=ppt/slides/slide16.xml><?xml version="1.0" encoding="utf-8"?>
+<file path=ppt/slides/slide17.xml><?xml version="1.0" encoding="utf-8"?>
 <p:sld xmlns:a="http://schemas.openxmlformats.org/drawingml/2006/main" xmlns:p="http://schemas.openxmlformats.org/presentationml/2006/main" xmlns:r="http://schemas.openxmlformats.org/officeDocument/2006/relationships">
   <p:cSld>
     <p:spTree>
@@ -6815,7 +6991,7 @@
 </p:sld>
 </file>
 
-<file path=ppt/slides/slide17.xml><?xml version="1.0" encoding="utf-8"?>
+<file path=ppt/slides/slide18.xml><?xml version="1.0" encoding="utf-8"?>
 <p:sld xmlns:a="http://schemas.openxmlformats.org/drawingml/2006/main" xmlns:p="http://schemas.openxmlformats.org/presentationml/2006/main" xmlns:r="http://schemas.openxmlformats.org/officeDocument/2006/relationships">
   <p:cSld>
     <p:spTree>
@@ -10049,7 +10225,7 @@
               </a:defRPr>
             </a:pPr>
             <a:r>
-              <a:t>All 4 independent cohorts point the same (negative) direction; pooled effect is statistically significant and OPPOSITE the original hypothesis. This is the central result of the dry-lab analysis.</a:t>
+              <a:t>Pooled effect (p=0.010) IS statistically significant and OPPOSITE the original hypothesis - even though 1 of 4 cohorts (GSE53845, n=40) was individually underpowered. But note I^2=83.5% (high heterogeneity): significance says the direction is real; heterogeneity says the SIZE of the effect is not uniform across cohorts. Two separate questions - both matter, and this is why the follow-up wet-lab time-course is needed to settle the magnitude question.</a:t>
             </a:r>
           </a:p>
         </p:txBody>

</xml_diff>

<commit_message>
Translate slide explanations/overview text to Korean
Per user request: slide titles and code (mirroring the actual English
R scripts) stay in English; every explanation box, overview bullet
list, and section-header subtitle is now in Korean. Table headers/
data and code comments are unchanged (technical/data labels, and
code should match the real scripts verbatim).

Verified: file re-opens cleanly, no leftover English explanation
text, text-capacity re-checked accounting for Korean characters being
wider per-glyph than Latin (all boxes still comfortably within their
box height).
</commit_message>
<xml_diff>
--- a/presentation/dry_lab_summary.pptx
+++ b/presentation/dry_lab_summary.pptx
@@ -3151,7 +3151,7 @@
                 </a:solidFill>
                 <a:latin typeface="Arial"/>
               </a:rPr>
-              <a:t>Public human fibrosis (GSE135251, GSE14323, GSE47460, GSE53845) + HCC-ICI (GSE215011, GSE279750, GSE235863) cohort analysis</a:t>
+              <a:t>공개 human 섬유화 코호트(GSE135251, GSE14323, GSE47460, GSE53845) + HCC 면역항암제 코호트(GSE215011, GSE279750, GSE235863) 분석</a:t>
             </a:r>
           </a:p>
           <a:p>
@@ -3397,7 +3397,7 @@
                 </a:solidFill>
                 <a:latin typeface="Arial"/>
               </a:rPr>
-              <a:t>HSF2 rises WITH overall immune infiltration (PTPRC, positive) but falls specifically with NETosis-core genes (negative) — opposite directions. Rules out the trivial "more immune cells = less relative HSF2" explanation.</a:t>
+              <a:t>HSF2는 전체 면역세포 침윤(PTPRC)과는 함께 증가(양의 상관)하지만 NETosis 핵심 유전자와는 특이적으로 감소(음의 상관) — 서로 반대 방향. "면역세포가 많아져서 HSF2 상대신호가 희석됐다"는 단순한 설명을 배제함.</a:t>
             </a:r>
           </a:p>
         </p:txBody>
@@ -3896,7 +3896,7 @@
                 </a:solidFill>
                 <a:latin typeface="Arial"/>
               </a:rPr>
-              <a:t>CAMP/MPO/DEFA4 (+ PADI4/ELANE with 1 small exception) move consistently negative with HSF2 in all 4 cohorts. LTF/NCF2/ITGAM/LCN2 actually flip sign between liver and lung — possibly not neutrophil-specific (e.g. LCN2 is also made by stressed hepatocytes).</a:t>
+              <a:t>CAMP/MPO/DEFA4(+ 작은 예외 하나씩 있는 PADI4/ELANE)는 4개 코호트 전부에서 HSF2와 일관되게 음의 방향. LTF/NCF2/ITGAM/LCN2는 간과 폐 사이에서 부호가 뒤집힘 — 호중구 특이적 신호가 아닐 가능성(예: LCN2는 스트레스 받은 간세포에서도 만들어짐).</a:t>
             </a:r>
           </a:p>
         </p:txBody>
@@ -4979,7 +4979,7 @@
                 </a:solidFill>
                 <a:latin typeface="Arial"/>
               </a:rPr>
-              <a:t>Across 8 evidence libraries (ChIP-seq + co-expression + literature), HSF2 is never a plausible top regulator of this gene set. Either a repressive relationship these tools can't detect, or genuinely unstudied territory (blue ocean).</a:t>
+              <a:t>8개의 증거 라이브러리(ChIP-seq + co-expression + literature) 전체에서 HSF2는 이 유전자 세트의 상위 조절인자로 한 번도 나오지 않음. 이 도구들이 못 잡는 억제성 관계이거나, 정말 미개척 영역(blue ocean)일 가능성.</a:t>
             </a:r>
           </a:p>
         </p:txBody>
@@ -5615,7 +5615,7 @@
                 </a:solidFill>
                 <a:latin typeface="Arial"/>
               </a:rPr>
-              <a:t>HCC = liver cancer, ICI = immune-checkpoint-inhibitor drugs. Does tumor HSF2 relate to whether real patients respond to immunotherapy?</a:t>
+              <a:t>HCC = 간암, ICI = 면역관문억제제. 실제 환자의 종양 HSF2가 면역항암제 반응 여부와 관련 있는가?</a:t>
             </a:r>
           </a:p>
         </p:txBody>
@@ -5902,7 +5902,7 @@
                 </a:solidFill>
                 <a:latin typeface="Arial"/>
               </a:rPr>
-              <a:t>Originally planned dataset didn't measure HSF2 at all - checked directly, excluded rather than substituting. Found GSE215011 instead (real RNA-seq). Alone, n=10 is too small to reach significance (rank-biserial r=0.44, p=0.30).</a:t>
+              <a:t>원래 계획했던 데이터셋은 HSF2를 아예 측정하지 않음 — 직접 확인 후 대체하지 않고 배제. 대신 GSE215011(실제 RNA-seq)을 찾아 사용. n=10 단독으로는 유의성 도달에 표본이 부족함(rank-biserial r=0.44, p=0.30).</a:t>
             </a:r>
           </a:p>
         </p:txBody>
@@ -6194,7 +6194,7 @@
                 </a:solidFill>
                 <a:latin typeface="Arial"/>
               </a:rPr>
-              <a:t>Patients with LOWER tumor HSF2 responded better to combination immunotherapy in both cohorts (both p&lt;0.05). Note: both are combination-regimen, post-treatment cohorts - different design from GSE215011's monotherapy.</a:t>
+              <a:t>두 코호트 모두에서 종양 HSF2가 낮은 환자일수록 병용 면역항암제에 더 잘 반응(둘 다 p&lt;0.05). 참고: 둘 다 병용요법·치료 후 코호트 — GSE215011의 단독요법과는 설계가 다름.</a:t>
             </a:r>
           </a:p>
         </p:txBody>
@@ -6486,7 +6486,7 @@
                 </a:solidFill>
                 <a:latin typeface="Arial"/>
               </a:rPr>
-              <a:t>IMPORTANT for grant "preliminary data" framing: 2 of 3 cohorts individually significant, but formal pooled meta-analysis is NOT significant (p=0.22, high heterogeneity). Present as a promising signal needing a larger validation cohort.</a:t>
+              <a:t>연구계획서 "preliminary data"로 쓸 때 중요: 3개 중 2개 코호트는 개별적으로 유의하지만, 정식 pooled meta-analysis는 비유의(p=0.22, 높은 이질성). "이미 증명됨"이 아니라 "더 큰 검증 코호트가 필요한 유망한 신호"로 제시해야 함.</a:t>
             </a:r>
           </a:p>
         </p:txBody>
@@ -6601,7 +6601,7 @@
                 </a:solidFill>
                 <a:latin typeface="Arial"/>
               </a:rPr>
-              <a:t>- Tested: HSF2 up -&gt; NETosis-gene expression up (positively correlated) in fibrotic tissue. Result in 4 independent human liver/lung cohorts: HSF2 is NEGATIVELY correlated with the NETosis-core score (pooled rho=-0.31, p=0.010), replicated in 3/4 cohorts, and specific (survives the PTPRC immune-infiltration control).</a:t>
+              <a:t>- 검증한 가설: 섬유화 조직에서 HSF2↑ → NETosis 유전자 발현↑(양의 상관). 결과: 4개의 독립적인 human 간·폐 코호트에서 HSF2는 NETosis_core score와 음의 상관(pooled rho=-0.31, p=0.010), 3/4 코호트에서 재현, PTPRC 면역침윤 대조도 통과한 특이적 신호.</a:t>
             </a:r>
           </a:p>
           <a:p>
@@ -6633,7 +6633,7 @@
                 </a:solidFill>
                 <a:latin typeface="Arial"/>
               </a:rPr>
-              <a:t>- No existing public ChIP-seq/co-expression database shows HSF2 activating these genes - genuinely unstudied territory.</a:t>
+              <a:t>- 기존 공개 ChIP-seq/co-expression 데이터베이스 어디에도 HSF2가 이 유전자들을 활성화한다는 근거 없음 — 정말 미개척 영역.</a:t>
             </a:r>
           </a:p>
           <a:p>
@@ -6665,7 +6665,7 @@
                 </a:solidFill>
                 <a:latin typeface="Arial"/>
               </a:rPr>
-              <a:t>- In 3 independent human HCC immunotherapy cohorts, lower tumor HSF2 trends toward better treatment response (2/3 individually significant; pooled result inconclusive, needs more data).</a:t>
+              <a:t>- 3개의 독립적인 human HCC 면역항암제 코호트에서 종양 HSF2가 낮을수록 치료 반응이 좋아지는 경향(3개 중 2개는 개별 유의; pooled 결과는 아직 불확실, 추가 데이터 필요).</a:t>
             </a:r>
           </a:p>
           <a:p>
@@ -6697,7 +6697,7 @@
                 </a:solidFill>
                 <a:latin typeface="Arial"/>
               </a:rPr>
-              <a:t>- Proposed reframing: HSF2 may not be the "master switch" that turns ON NETosis together with N2 polarization - it may instead "decouple" the two, acting as a brake specifically on the NETosis arm while the broader N2/immunosuppressive program proceeds.</a:t>
+              <a:t>- 제안하는 재해석: HSF2는 N2 극성화와 NETosis를 함께 켜는 "총사령관"이 아니라, 오히려 둘을 "분리(decouple)"시켜서 — 더 넓은 N2/면역억제 프로그램은 진행되게 두면서 NETosis 쪽에만 브레이크를 거는 조절자일 수 있음.</a:t>
             </a:r>
           </a:p>
         </p:txBody>
@@ -6788,7 +6788,7 @@
                 </a:solidFill>
                 <a:latin typeface="Arial"/>
               </a:rPr>
-              <a:t>- The first lab experiment (PHMG 6 mg/kg in vivo -&gt; neutrophil RNA-seq -&gt; HSF2 ranked #1 upstream TF of the upregulated genes) is the missing piece that could directly test the "decoupling" idea above.</a:t>
+              <a:t>- 연구실의 첫 실험(PHMG 6 mg/kg in vivo → 호중구 RNA-seq → 상승 유전자군의 1순위 상위 TF가 HSF2)이 바로 위 "decoupling" 가설을 직접 검증할 수 있는 빠진 조각입니다.</a:t>
             </a:r>
           </a:p>
           <a:p>
@@ -6820,7 +6820,7 @@
                 </a:solidFill>
                 <a:latin typeface="Arial"/>
               </a:rPr>
-              <a:t>- Request: the list of genes UPREGULATED in that in vivo experiment (or the gene set fed into the TF-enrichment analysis).</a:t>
+              <a:t>- 요청: 그 in vivo 실험에서 상승(upregulated)한 유전자 리스트(또는 TF-enrichment 분석에 입력한 유전자셋).</a:t>
             </a:r>
           </a:p>
           <a:p>
@@ -6852,7 +6852,7 @@
                 </a:solidFill>
                 <a:latin typeface="Arial"/>
               </a:rPr>
-              <a:t>- If PADI4/ELANE/MPO/CAMP/DEFA4 were part of that upregulated set -&gt; HSF2 and NETosis genes moved together in vivo -&gt; tension with the human tissue finding, needs reconciling.</a:t>
+              <a:t>- 만약 PADI4/ELANE/MPO/CAMP/DEFA4가 그 상승 유전자 목록에 포함되어 있었다면 → in vivo에서는 HSF2와 NETosis 유전자가 같이 움직였다는 뜻 → human 조직 결과와 상충, 조정이 필요.</a:t>
             </a:r>
           </a:p>
           <a:p>
@@ -6884,7 +6884,7 @@
                 </a:solidFill>
                 <a:latin typeface="Arial"/>
               </a:rPr>
-              <a:t>- If those genes were NOT in the upregulated set (flat or down) -&gt; directly SUPPORTS the decoupling hypothesis using the lab's own mouse data, not just outside public data.</a:t>
+              <a:t>- 만약 그 유전자들이 상승 목록에 없었다면(변화 없음 또는 감소) → 외부 공개 데이터뿐 아니라 우리 연구실 자체 마우스 데이터로도 decoupling 가설이 직접 뒷받침됨.</a:t>
             </a:r>
           </a:p>
         </p:txBody>
@@ -6975,7 +6975,7 @@
                 </a:solidFill>
                 <a:latin typeface="Arial"/>
               </a:rPr>
-              <a:t>- Planned: PHMG dose/time-course in isolated neutrophils (building on the single 3 ug/mL, 6h Western blot result).</a:t>
+              <a:t>- 계획: 분리된 호중구에서 PHMG 농도/시간별 실험(기존 3 ug/mL, 6시간 단일 Western blot 결과에서 확장).</a:t>
             </a:r>
           </a:p>
           <a:p>
@@ -7007,7 +7007,7 @@
                 </a:solidFill>
                 <a:latin typeface="Arial"/>
               </a:rPr>
-              <a:t>- Suggested addition: full time course (1h/2h/4h/6h), not a single timepoint, tracking BOTH (a) HSF2 protein/mRNA and (b) NETosis-core mRNA (PADI4, ELANE, MPO, CAMP, DEFA4 by qPCR), alongside standard N1 (iNOS, TNF-a, ICAM-1) and N2 (Arg-1, CD206, IL-10) markers, plus one functional NETosis readout (extracellular DNA/SYTOX assay).</a:t>
+              <a:t>- 제안하는 추가사항: 단일 시점이 아닌 전체 time course(1h/2h/4h/6h)로 (a) HSF2 단백질/mRNA와 (b) NETosis 핵심 mRNA(PADI4, ELANE, MPO, CAMP, DEFA4, qPCR)를 함께 추적하고, 표준 N1(iNOS, TNF-α, ICAM-1)·N2(Arg-1, CD206, IL-10) 마커도 같이, 여기에 기능적 NETosis readout(세포외 DNA/SYTOX assay) 하나 추가.</a:t>
             </a:r>
           </a:p>
           <a:p>
@@ -7039,7 +7039,7 @@
                 </a:solidFill>
                 <a:latin typeface="Arial"/>
               </a:rPr>
-              <a:t>- Prediction from dry-lab data: as HSF2 rises, PADI4/ELANE/MPO/CAMP/DEFA4 will NOT rise in parallel, while Arg-1/CD206 rise together with HSF2 - N2 polarization and NETosis-gene induction become decoupled under toxicant stress.</a:t>
+              <a:t>- Dry-lab 데이터에 근거한 예측: HSF2가 오를 때 PADI4/ELANE/MPO/CAMP/DEFA4는 같이 오르지 않고, Arg-1/CD206은 HSF2와 함께 오를 것 — 독성 스트레스 하에서 N2 극성화와 NETosis 유전자 유도가 decoupling됨.</a:t>
             </a:r>
           </a:p>
           <a:p>
@@ -7071,7 +7071,7 @@
                 </a:solidFill>
                 <a:latin typeface="Arial"/>
               </a:rPr>
-              <a:t>- Either outcome (confirmed or refuted) is a real, reportable finding.</a:t>
+              <a:t>- 어느 쪽 결과가 나오든(확인되든 반박되든) 그 자체로 의미 있는, 보고 가능한 발견입니다.</a:t>
             </a:r>
           </a:p>
         </p:txBody>
@@ -7162,7 +7162,7 @@
                 </a:solidFill>
                 <a:latin typeface="Arial"/>
               </a:rPr>
-              <a:t>- Lab's wet-lab experiments: PHMG 6 mg/kg in vivo mouse neutrophil RNA-seq -&gt; HSF2 ranked #1 upstream TF of upregulated genes; ex vivo PHMG 3 ug/mL, 6h -&gt; Western blot shows a thicker HSF2 band.</a:t>
+              <a:t>- 연구실 웻랩 실험: PHMG 6 mg/kg in vivo 마우스 호중구 RNA-seq → 상승(upregulated) 유전자군의 1순위 상위 TF로 HSF2 확인; ex vivo PHMG 3 ug/mL, 6시간 처리 → Western blot에서 HSF2 band 두꺼워짐 관찰.</a:t>
             </a:r>
           </a:p>
           <a:p>
@@ -7178,7 +7178,7 @@
                 </a:solidFill>
                 <a:latin typeface="Arial"/>
               </a:rPr>
-              <a:t>- Working hypothesis: PHMG -&gt; HSF2 activation -&gt; N2 (immunosuppressive) neutrophil polarization -&gt; NETosis-gene induction -&gt; fibrosis / HCC immune evasion.</a:t>
+              <a:t>- 작업 가설: PHMG → HSF2 활성화 → N2(면역억제성) 호중구 극성화 → NETosis 유전자 발현 유도 → 섬유화 / 간암(HCC) 면역회피.</a:t>
             </a:r>
           </a:p>
           <a:p>
@@ -7194,7 +7194,7 @@
                 </a:solidFill>
                 <a:latin typeface="Arial"/>
               </a:rPr>
-              <a:t>- This deck: before more wet-lab work, tests the population-level prediction of that hypothesis (HSF2 up -&gt; NETosis-core genes up) using 4 independent public human fibrosis cohorts, then extends to 3 independent HCC immunotherapy-response cohorts.</a:t>
+              <a:t>- 이 자료의 목적: 추가 웻랩 실험 전에, 이 가설의 population-level 예측(HSF2↑ → NETosis 핵심 유전자↑)을 4개의 독립적인 공개 human 섬유화 코호트로 먼저 검증하고, 3개의 독립적인 HCC 면역항암제 반응성 코호트로 확장 분석.</a:t>
             </a:r>
           </a:p>
           <a:p>
@@ -7210,7 +7210,7 @@
                 </a:solidFill>
                 <a:latin typeface="Arial"/>
               </a:rPr>
-              <a:t>- 12 R scripts total (scripts/00-12 in the repo), all pre-registered before results were seen: primary endpoint, replication rule, specificity control, in silico TF check, and meta-analyses throughout.</a:t>
+              <a:t>- 총 12개 R 스크립트(repo의 scripts/00-12) — 결과를 보기 전에 미리 지정한 분석계획: 1차 endpoint, 재현성 규칙, 특이성 대조, in silico TF 검증, 전체 meta-analysis까지 포함.</a:t>
             </a:r>
           </a:p>
           <a:p>
@@ -7226,7 +7226,7 @@
                 </a:solidFill>
                 <a:latin typeface="Arial"/>
               </a:rPr>
-              <a:t>- This PPT walks through every script's code, actual output, and a one-line interpretation, in the order the analysis was actually run.</a:t>
+              <a:t>- 이 PPT는 실제 분석이 진행된 순서 그대로, 각 스크립트의 코드·실제 결과·한 줄 해석을 정리했습니다.</a:t>
             </a:r>
           </a:p>
         </p:txBody>
@@ -7294,7 +7294,7 @@
                 </a:solidFill>
                 <a:latin typeface="Arial"/>
               </a:rPr>
-              <a:t>Does HSF2 positively correlate with NETosis-core genes in fibrotic liver/lung tissue?</a:t>
+              <a:t>섬유화된 간·폐 조직에서 HSF2가 NETosis 핵심 유전자와 양의 상관관계를 보이는가?</a:t>
             </a:r>
           </a:p>
         </p:txBody>
@@ -7619,7 +7619,7 @@
                 </a:solidFill>
                 <a:latin typeface="Arial"/>
               </a:rPr>
-              <a:t>If HSF2 drives NETosis-gene expression, HSF2 should POSITIVELY correlate with PADI4/ELANE/MPO in fibrotic tissue, reproducibly across independent cohorts. This plan was fixed before any correlation was computed.</a:t>
+              <a:t>HSF2가 NETosis 유전자 발현을 유도한다면, 섬유화 조직에서 HSF2는 PADI4/ELANE/MPO와 양의 상관관계를 보여야 하고, 독립적인 코호트들에서 재현되어야 함. 이 계획은 실제 상관관계를 계산해보기 전에 미리 고정함.</a:t>
             </a:r>
           </a:p>
         </p:txBody>
@@ -8365,7 +8365,7 @@
                 </a:solidFill>
                 <a:latin typeface="Arial"/>
               </a:rPr>
-              <a:t>Result is OPPOSITE the original hypothesis: HSF2 correlates negatively with the NETosis-core score in fibrotic liver tissue.</a:t>
+              <a:t>결과는 원 가설과 반대 방향: 섬유화된 간 조직에서 HSF2는 NETosis_core score와 음의 상관관계를 보임.</a:t>
             </a:r>
           </a:p>
         </p:txBody>
@@ -8676,7 +8676,7 @@
                 </a:solidFill>
                 <a:latin typeface="Arial"/>
               </a:rPr>
-              <a:t>Independent platform, independent patients — same negative direction, much stronger (rho=-0.550, p=6.2e-09). Formally REPLICATES the liver finding.</a:t>
+              <a:t>독립적인 플랫폼, 독립적인 환자군 — 같은 음의 방향, 훨씬 강함(rho=-0.550, p=6.2e-09). 간 코호트 결과가 공식적으로 재현(REPLICATE)됨.</a:t>
             </a:r>
           </a:p>
         </p:txBody>
@@ -8949,7 +8949,7 @@
                 </a:solidFill>
                 <a:latin typeface="Arial"/>
               </a:rPr>
-              <a:t>Different organ (lung, not liver), different platform — same negative direction, highly significant (rho=-0.392, p=8.1e-06). Pattern is not liver-specific.</a:t>
+              <a:t>다른 장기(간이 아닌 폐), 다른 플랫폼 — 같은 음의 방향, 매우 유의함(rho=-0.392, p=8.1e-06). 간에만 국한된 패턴이 아님.</a:t>
             </a:r>
           </a:p>
         </p:txBody>
@@ -9260,7 +9260,7 @@
                 </a:solidFill>
                 <a:latin typeface="Arial"/>
               </a:rPr>
-              <a:t>Direction still negative but n=40 is underpowered - not individually significant. Treated as "no information," not contradicting evidence; carried into the meta-analysis.</a:t>
+              <a:t>방향은 여전히 음의 상관이지만 n=40은 검정력 부족 — 개별적으로는 비유의. "반증"이 아니라 "정보 없음"으로 취급하고, meta-analysis에 그대로 포함시킴.</a:t>
             </a:r>
           </a:p>
         </p:txBody>
@@ -9552,7 +9552,7 @@
                 </a:solidFill>
                 <a:latin typeface="Arial"/>
               </a:rPr>
-              <a:t>Pooled rho=-0.308 (p=0.010) IS significant and OPPOSITE the hypothesis, even though GSE53845 alone was underpowered. But I^2=83.5% (high heterogeneity): significance says the direction is real; heterogeneity says the effect SIZE is not uniform across cohorts — two separate questions. The wet-lab time-course is what settles the magnitude question.</a:t>
+              <a:t>Pooled rho=-0.308(p=0.010)는 유의하며 가설과 반대 방향 — GSE53845 단독은 검정력 부족이었지만 무관함. 다만 I^2=83.5%(높은 이질성): 유의성은 "방향이 진짜"라는 뜻이고, 이질성은 "효과 크기가 코호트마다 일정하지 않다"는 별개의 질문. 이 크기 문제를 해결해줄 게 웻랩 time-course 실험.</a:t>
             </a:r>
           </a:p>
         </p:txBody>

</xml_diff>